<commit_message>
Update slides and report for --symbols and 35 checks
</commit_message>
<xml_diff>
--- a/docs/final_review.pptx
+++ b/docs/final_review.pptx
@@ -634,7 +634,7 @@
           <a:lstStyle/>
           <a:p>
             <a:r>
-              <a:t>All code for Reviews 2 and 3 is finished and tested: 32 of 32 checks pass. What remains is the manuscript and the final report for the VTOP upload on Oct 30.</a:t>
+              <a:t>All code for Reviews 2 and 3 is finished and tested: 35 of 35 checks pass. What remains is the manuscript and the final report for the VTOP upload on Oct 30.</a:t>
             </a:r>
           </a:p>
         </p:txBody>
@@ -2700,7 +2700,7 @@
                 <a:ea typeface="Cambria" pitchFamily="34" charset="-122"/>
                 <a:cs typeface="Cambria" pitchFamily="34" charset="-120"/>
               </a:rPr>
-              <a:t>32</a:t>
+              <a:t>35</a:t>
             </a:r>
             <a:endParaRPr lang="en-US" sz="4400" dirty="0"/>
           </a:p>
@@ -2736,7 +2736,7 @@
                   <a:schemeClr val="tx1"/>
                 </a:solidFill>
               </a:rPr>
-              <a:t>of 32 checks pass</a:t>
+              <a:t>of 35 checks pass</a:t>
             </a:r>
             <a:endParaRPr lang="en-US" sz="1600" dirty="0"/>
           </a:p>
@@ -2772,7 +2772,7 @@
                   <a:schemeClr val="tx2"/>
                 </a:solidFill>
               </a:rPr>
-              <a:t>17 programs, 15 also two-pass</a:t>
+              <a:t>19 programs, 16 also two-pass</a:t>
             </a:r>
             <a:endParaRPr lang="en-US" sz="1200" dirty="0"/>
           </a:p>
@@ -3292,7 +3292,7 @@
                   <a:schemeClr val="tx1"/>
                 </a:solidFill>
               </a:rPr>
-              <a:t>The two-pass baseline prints identical code for every test program</a:t>
+              <a:t>The two-pass baseline prints identical output on all 16 tests they share</a:t>
             </a:r>
             <a:endParaRPr lang="en-US" sz="1600" dirty="0"/>
           </a:p>
@@ -5266,7 +5266,7 @@
                   <a:schemeClr val="tx1"/>
                 </a:solidFill>
               </a:rPr>
-              <a:t>Both programs print identical quadruples for all 15 test programs, which cross-checks every semantic action. Backpatching holds only the jumps still waiting for a target; the two-pass compiler holds the whole program until its labels are resolved.</a:t>
+              <a:t>Both programs print identical output, error messages included, for all 16 test programs run through both, which cross-checks every semantic action. Backpatching holds only the jumps still waiting for a target; the two-pass compiler holds the whole program until its labels are resolved.</a:t>
             </a:r>
             <a:endParaRPr lang="en-US" sz="1600" dirty="0"/>
           </a:p>
@@ -12480,7 +12480,7 @@
                           <a:ea typeface="Courier New" pitchFamily="34" charset="-122"/>
                           <a:cs typeface="Courier New" pitchFamily="34" charset="-120"/>
                         </a:rPr>
-                        <a:t>symtab_insert()</a:t>
+                        <a:t>symtab_insert, print_symbols</a:t>
                       </a:r>
                       <a:endParaRPr lang="en-US" sz="1400" dirty="0">
                         <a:latin typeface="Courier New" charset="0"/>

</xml_diff>